<commit_message>
Align Lab 10 with group project and publish revised theory/practical slides
</commit_message>
<xml_diff>
--- a/slides/LAB10_Monitoring_Status_Bukti_Live.pptx
+++ b/slides/LAB10_Monitoring_Status_Bukti_Live.pptx
@@ -2,25 +2,25 @@
 <file path=ppt/presentation.xml><?xml version="1.0" encoding="utf-8"?>
 <p:presentation xmlns:p="http://schemas.openxmlformats.org/presentationml/2006/main">
   <p:sldMasterIdLst>
-    <p:sldMasterId xmlns:r="http://schemas.openxmlformats.org/officeDocument/2006/relationships" id="2147483648" r:id="R1a3075f184d64273"/>
+    <p:sldMasterId xmlns:r="http://schemas.openxmlformats.org/officeDocument/2006/relationships" id="2147483648" r:id="R48ccf4ac9c454b8a"/>
   </p:sldMasterIdLst>
   <p:notesMasterIdLst>
-    <p:notesMasterId xmlns:r="http://schemas.openxmlformats.org/officeDocument/2006/relationships" r:id="R42d8f837c3864318"/>
+    <p:notesMasterId xmlns:r="http://schemas.openxmlformats.org/officeDocument/2006/relationships" r:id="R4e7a08b074244823"/>
   </p:notesMasterIdLst>
   <p:sldIdLst>
-    <p:sldId xmlns:r="http://schemas.openxmlformats.org/officeDocument/2006/relationships" id="256" r:id="Rd059ddd5a0444c17"/>
-    <p:sldId xmlns:r="http://schemas.openxmlformats.org/officeDocument/2006/relationships" id="257" r:id="R9f44533e24f04ff7"/>
-    <p:sldId xmlns:r="http://schemas.openxmlformats.org/officeDocument/2006/relationships" id="258" r:id="Ree65b4f1009c44cd"/>
-    <p:sldId xmlns:r="http://schemas.openxmlformats.org/officeDocument/2006/relationships" id="259" r:id="R05b2492727784763"/>
-    <p:sldId xmlns:r="http://schemas.openxmlformats.org/officeDocument/2006/relationships" id="260" r:id="R260a47c812224128"/>
-    <p:sldId xmlns:r="http://schemas.openxmlformats.org/officeDocument/2006/relationships" id="261" r:id="R747b46b2974a480f"/>
-    <p:sldId xmlns:r="http://schemas.openxmlformats.org/officeDocument/2006/relationships" id="262" r:id="Reace4bcbb43c45b2"/>
-    <p:sldId xmlns:r="http://schemas.openxmlformats.org/officeDocument/2006/relationships" id="263" r:id="R3a2a483dcb434840"/>
-    <p:sldId xmlns:r="http://schemas.openxmlformats.org/officeDocument/2006/relationships" id="264" r:id="Rdc3292e3e97b4f21"/>
-    <p:sldId xmlns:r="http://schemas.openxmlformats.org/officeDocument/2006/relationships" id="265" r:id="Re8972b3150a1484a"/>
-    <p:sldId xmlns:r="http://schemas.openxmlformats.org/officeDocument/2006/relationships" id="266" r:id="R1afc0ec1b8954986"/>
-    <p:sldId xmlns:r="http://schemas.openxmlformats.org/officeDocument/2006/relationships" id="267" r:id="R392a89f246c0498a"/>
-    <p:sldId xmlns:r="http://schemas.openxmlformats.org/officeDocument/2006/relationships" id="268" r:id="R5fe2336d28da4b44"/>
+    <p:sldId xmlns:r="http://schemas.openxmlformats.org/officeDocument/2006/relationships" id="256" r:id="R8270bf3d3ea142a8"/>
+    <p:sldId xmlns:r="http://schemas.openxmlformats.org/officeDocument/2006/relationships" id="257" r:id="R936513b794c7445e"/>
+    <p:sldId xmlns:r="http://schemas.openxmlformats.org/officeDocument/2006/relationships" id="258" r:id="R0474660e9f74441c"/>
+    <p:sldId xmlns:r="http://schemas.openxmlformats.org/officeDocument/2006/relationships" id="259" r:id="R1b5aaab5bbe947cf"/>
+    <p:sldId xmlns:r="http://schemas.openxmlformats.org/officeDocument/2006/relationships" id="260" r:id="Rf859e2f64252461b"/>
+    <p:sldId xmlns:r="http://schemas.openxmlformats.org/officeDocument/2006/relationships" id="261" r:id="R73f25f9d84ed4287"/>
+    <p:sldId xmlns:r="http://schemas.openxmlformats.org/officeDocument/2006/relationships" id="262" r:id="R9e289dbbddd943ac"/>
+    <p:sldId xmlns:r="http://schemas.openxmlformats.org/officeDocument/2006/relationships" id="263" r:id="R1950737dcedc47e1"/>
+    <p:sldId xmlns:r="http://schemas.openxmlformats.org/officeDocument/2006/relationships" id="264" r:id="Rea757c56f7764041"/>
+    <p:sldId xmlns:r="http://schemas.openxmlformats.org/officeDocument/2006/relationships" id="265" r:id="R4b9404e04703427c"/>
+    <p:sldId xmlns:r="http://schemas.openxmlformats.org/officeDocument/2006/relationships" id="266" r:id="Rd4e1708e172e46f4"/>
+    <p:sldId xmlns:r="http://schemas.openxmlformats.org/officeDocument/2006/relationships" id="267" r:id="Rb6afe2a0e9da4da2"/>
+    <p:sldId xmlns:r="http://schemas.openxmlformats.org/officeDocument/2006/relationships" id="268" r:id="R3f65ba722efe4038"/>
   </p:sldIdLst>
   <p:sldSz cx="12192000" cy="6858000"/>
   <p:notesSz cx="6858000" cy="9144000"/>
@@ -1379,7 +1379,7 @@
   </p:cSld>
   <p:clrMap bg1="lt1" tx1="dk1" bg2="lt2" tx2="dk2" accent1="accent1" accent2="accent2" accent3="accent3" accent4="accent4" accent5="accent5" accent6="accent6" hlink="hlink" folHlink="folHlink"/>
   <p:sldLayoutIdLst>
-    <p:sldLayoutId xmlns:r="http://schemas.openxmlformats.org/officeDocument/2006/relationships" id="2147483649" r:id="R6fa06650f0a34b34"/>
+    <p:sldLayoutId xmlns:r="http://schemas.openxmlformats.org/officeDocument/2006/relationships" id="2147483649" r:id="R6bfeb947ae124d43"/>
   </p:sldLayoutIdLst>
   <p:hf sldNum="0" hdr="0" ftr="0" dt="0"/>
   <p:txStyles>
@@ -1932,7 +1932,7 @@
     <p:bg>
       <p:bgPr>
         <a:blipFill xmlns:a="http://schemas.openxmlformats.org/drawingml/2006/main" rotWithShape="1">
-          <a:blip xmlns:r="http://schemas.openxmlformats.org/officeDocument/2006/relationships" r:embed="Rb8dcf6eea1f243a8">
+          <a:blip xmlns:r="http://schemas.openxmlformats.org/officeDocument/2006/relationships" r:embed="Rc8c51fc794c34d6d">
             <a:lum/>
           </a:blip>
           <a:srcRect l="0" t="0" r="0" b="0"/>
@@ -1960,7 +1960,7 @@
           <p:nvPr/>
         </p:nvPicPr>
         <p:blipFill>
-          <a:blip xmlns:r="http://schemas.openxmlformats.org/officeDocument/2006/relationships" xmlns:a="http://schemas.openxmlformats.org/drawingml/2006/main" r:embed="Ra68017254c4c4029"/>
+          <a:blip xmlns:r="http://schemas.openxmlformats.org/officeDocument/2006/relationships" xmlns:a="http://schemas.openxmlformats.org/drawingml/2006/main" r:embed="R9e4d962db0334be1"/>
           <a:stretch xmlns:a="http://schemas.openxmlformats.org/drawingml/2006/main">
             <a:fillRect l="0" t="0" r="0" b="0"/>
           </a:stretch>
@@ -1984,7 +1984,7 @@
           <p:nvPr/>
         </p:nvPicPr>
         <p:blipFill>
-          <a:blip xmlns:r="http://schemas.openxmlformats.org/officeDocument/2006/relationships" xmlns:a="http://schemas.openxmlformats.org/drawingml/2006/main" r:embed="R120d7d9a931e4bec"/>
+          <a:blip xmlns:r="http://schemas.openxmlformats.org/officeDocument/2006/relationships" xmlns:a="http://schemas.openxmlformats.org/drawingml/2006/main" r:embed="R3fa7a7dbd64941f6"/>
           <a:stretch xmlns:a="http://schemas.openxmlformats.org/drawingml/2006/main">
             <a:fillRect l="0" t="0" r="0" b="0"/>
           </a:stretch>
@@ -2527,7 +2527,7 @@
           <p:nvPr/>
         </p:nvPicPr>
         <p:blipFill>
-          <a:blip xmlns:r="http://schemas.openxmlformats.org/officeDocument/2006/relationships" xmlns:a="http://schemas.openxmlformats.org/drawingml/2006/main" r:embed="R05fe96acff0f4547"/>
+          <a:blip xmlns:r="http://schemas.openxmlformats.org/officeDocument/2006/relationships" xmlns:a="http://schemas.openxmlformats.org/drawingml/2006/main" r:embed="R40d4c473b8884b72"/>
           <a:stretch xmlns:a="http://schemas.openxmlformats.org/drawingml/2006/main">
             <a:fillRect l="0" t="0" r="0" b="0"/>
           </a:stretch>
@@ -2551,7 +2551,7 @@
           <p:nvPr/>
         </p:nvPicPr>
         <p:blipFill>
-          <a:blip xmlns:r="http://schemas.openxmlformats.org/officeDocument/2006/relationships" xmlns:a="http://schemas.openxmlformats.org/drawingml/2006/main" r:embed="Rc25b3247f8274965"/>
+          <a:blip xmlns:r="http://schemas.openxmlformats.org/officeDocument/2006/relationships" xmlns:a="http://schemas.openxmlformats.org/drawingml/2006/main" r:embed="R44d5a0cb9c4f48c7"/>
           <a:stretch xmlns:a="http://schemas.openxmlformats.org/drawingml/2006/main">
             <a:fillRect l="0" t="0" r="0" b="0"/>
           </a:stretch>
@@ -3457,7 +3457,7 @@
           <p:nvPr/>
         </p:nvPicPr>
         <p:blipFill>
-          <a:blip xmlns:r="http://schemas.openxmlformats.org/officeDocument/2006/relationships" xmlns:a="http://schemas.openxmlformats.org/drawingml/2006/main" r:embed="Rcac7535abce343ec"/>
+          <a:blip xmlns:r="http://schemas.openxmlformats.org/officeDocument/2006/relationships" xmlns:a="http://schemas.openxmlformats.org/drawingml/2006/main" r:embed="R46081f7c0f964b6b"/>
           <a:stretch xmlns:a="http://schemas.openxmlformats.org/drawingml/2006/main">
             <a:fillRect l="0" t="0" r="0" b="0"/>
           </a:stretch>
@@ -3481,7 +3481,7 @@
           <p:nvPr/>
         </p:nvPicPr>
         <p:blipFill>
-          <a:blip xmlns:r="http://schemas.openxmlformats.org/officeDocument/2006/relationships" xmlns:a="http://schemas.openxmlformats.org/drawingml/2006/main" r:embed="Rb5e227bca3f644b5"/>
+          <a:blip xmlns:r="http://schemas.openxmlformats.org/officeDocument/2006/relationships" xmlns:a="http://schemas.openxmlformats.org/drawingml/2006/main" r:embed="R33c1bab5c321469b"/>
           <a:stretch xmlns:a="http://schemas.openxmlformats.org/drawingml/2006/main">
             <a:fillRect l="0" t="0" r="0" b="0"/>
           </a:stretch>
@@ -4385,7 +4385,7 @@
           <p:nvPr/>
         </p:nvPicPr>
         <p:blipFill>
-          <a:blip xmlns:r="http://schemas.openxmlformats.org/officeDocument/2006/relationships" xmlns:a="http://schemas.openxmlformats.org/drawingml/2006/main" r:embed="R4eac6c6898fb40a2"/>
+          <a:blip xmlns:r="http://schemas.openxmlformats.org/officeDocument/2006/relationships" xmlns:a="http://schemas.openxmlformats.org/drawingml/2006/main" r:embed="R9b4fabb3221f4b18"/>
           <a:stretch xmlns:a="http://schemas.openxmlformats.org/drawingml/2006/main">
             <a:fillRect l="0" t="0" r="0" b="0"/>
           </a:stretch>
@@ -4409,7 +4409,7 @@
           <p:nvPr/>
         </p:nvPicPr>
         <p:blipFill>
-          <a:blip xmlns:r="http://schemas.openxmlformats.org/officeDocument/2006/relationships" xmlns:a="http://schemas.openxmlformats.org/drawingml/2006/main" r:embed="R039fab14d5d342fb"/>
+          <a:blip xmlns:r="http://schemas.openxmlformats.org/officeDocument/2006/relationships" xmlns:a="http://schemas.openxmlformats.org/drawingml/2006/main" r:embed="Rdba2ad0fba664d31"/>
           <a:stretch xmlns:a="http://schemas.openxmlformats.org/drawingml/2006/main">
             <a:fillRect l="0" t="0" r="0" b="0"/>
           </a:stretch>
@@ -4645,7 +4645,7 @@
           <p:nvPr/>
         </p:nvPicPr>
         <p:blipFill>
-          <a:blip xmlns:r="http://schemas.openxmlformats.org/officeDocument/2006/relationships" xmlns:a="http://schemas.openxmlformats.org/drawingml/2006/main" r:embed="Ref6ebf3b92ee4d0c"/>
+          <a:blip xmlns:r="http://schemas.openxmlformats.org/officeDocument/2006/relationships" xmlns:a="http://schemas.openxmlformats.org/drawingml/2006/main" r:embed="R8a63bb569049493d"/>
           <a:stretch xmlns:a="http://schemas.openxmlformats.org/drawingml/2006/main">
             <a:fillRect l="0" t="0" r="0" b="0"/>
           </a:stretch>
@@ -4722,7 +4722,7 @@
           <p:nvPr/>
         </p:nvPicPr>
         <p:blipFill>
-          <a:blip xmlns:r="http://schemas.openxmlformats.org/officeDocument/2006/relationships" xmlns:a="http://schemas.openxmlformats.org/drawingml/2006/main" r:embed="R9a1c7a2d839a4425"/>
+          <a:blip xmlns:r="http://schemas.openxmlformats.org/officeDocument/2006/relationships" xmlns:a="http://schemas.openxmlformats.org/drawingml/2006/main" r:embed="Rc75782e319634b8d"/>
           <a:stretch xmlns:a="http://schemas.openxmlformats.org/drawingml/2006/main">
             <a:fillRect l="0" t="0" r="0" b="0"/>
           </a:stretch>
@@ -4799,7 +4799,7 @@
           <p:nvPr/>
         </p:nvPicPr>
         <p:blipFill>
-          <a:blip xmlns:r="http://schemas.openxmlformats.org/officeDocument/2006/relationships" xmlns:a="http://schemas.openxmlformats.org/drawingml/2006/main" r:embed="R5c4296e9dda04cc5"/>
+          <a:blip xmlns:r="http://schemas.openxmlformats.org/officeDocument/2006/relationships" xmlns:a="http://schemas.openxmlformats.org/drawingml/2006/main" r:embed="R37f2fb917d2a436c"/>
           <a:stretch xmlns:a="http://schemas.openxmlformats.org/drawingml/2006/main">
             <a:fillRect l="0" t="0" r="0" b="0"/>
           </a:stretch>
@@ -4876,7 +4876,7 @@
           <p:nvPr/>
         </p:nvPicPr>
         <p:blipFill>
-          <a:blip xmlns:r="http://schemas.openxmlformats.org/officeDocument/2006/relationships" xmlns:a="http://schemas.openxmlformats.org/drawingml/2006/main" r:embed="Reed27e8280d14b08"/>
+          <a:blip xmlns:r="http://schemas.openxmlformats.org/officeDocument/2006/relationships" xmlns:a="http://schemas.openxmlformats.org/drawingml/2006/main" r:embed="R5de3be6b6a3949fb"/>
           <a:stretch xmlns:a="http://schemas.openxmlformats.org/drawingml/2006/main">
             <a:fillRect l="0" t="0" r="0" b="0"/>
           </a:stretch>
@@ -4953,7 +4953,7 @@
           <p:nvPr/>
         </p:nvPicPr>
         <p:blipFill>
-          <a:blip xmlns:r="http://schemas.openxmlformats.org/officeDocument/2006/relationships" xmlns:a="http://schemas.openxmlformats.org/drawingml/2006/main" r:embed="Rb7e8484e91674fd7"/>
+          <a:blip xmlns:r="http://schemas.openxmlformats.org/officeDocument/2006/relationships" xmlns:a="http://schemas.openxmlformats.org/drawingml/2006/main" r:embed="R03e803b019364cb8"/>
           <a:stretch xmlns:a="http://schemas.openxmlformats.org/drawingml/2006/main">
             <a:fillRect l="0" t="0" r="0" b="0"/>
           </a:stretch>
@@ -5030,7 +5030,7 @@
           <p:nvPr/>
         </p:nvPicPr>
         <p:blipFill>
-          <a:blip xmlns:r="http://schemas.openxmlformats.org/officeDocument/2006/relationships" xmlns:a="http://schemas.openxmlformats.org/drawingml/2006/main" r:embed="R152e360ac986400d"/>
+          <a:blip xmlns:r="http://schemas.openxmlformats.org/officeDocument/2006/relationships" xmlns:a="http://schemas.openxmlformats.org/drawingml/2006/main" r:embed="Re298d34d0d0f4ac2"/>
           <a:stretch xmlns:a="http://schemas.openxmlformats.org/drawingml/2006/main">
             <a:fillRect l="0" t="0" r="0" b="0"/>
           </a:stretch>
@@ -5107,7 +5107,7 @@
           <p:nvPr/>
         </p:nvPicPr>
         <p:blipFill>
-          <a:blip xmlns:r="http://schemas.openxmlformats.org/officeDocument/2006/relationships" xmlns:a="http://schemas.openxmlformats.org/drawingml/2006/main" r:embed="Re07e961ae8f04d61"/>
+          <a:blip xmlns:r="http://schemas.openxmlformats.org/officeDocument/2006/relationships" xmlns:a="http://schemas.openxmlformats.org/drawingml/2006/main" r:embed="R051ba07aa50f49be"/>
           <a:stretch xmlns:a="http://schemas.openxmlformats.org/drawingml/2006/main">
             <a:fillRect l="0" t="0" r="0" b="0"/>
           </a:stretch>
@@ -5397,7 +5397,7 @@
           <p:nvPr/>
         </p:nvPicPr>
         <p:blipFill>
-          <a:blip xmlns:r="http://schemas.openxmlformats.org/officeDocument/2006/relationships" xmlns:a="http://schemas.openxmlformats.org/drawingml/2006/main" r:embed="R90ac75ce9fdf4c36"/>
+          <a:blip xmlns:r="http://schemas.openxmlformats.org/officeDocument/2006/relationships" xmlns:a="http://schemas.openxmlformats.org/drawingml/2006/main" r:embed="Rb1a9b96646c04972"/>
           <a:stretch xmlns:a="http://schemas.openxmlformats.org/drawingml/2006/main">
             <a:fillRect l="0" t="0" r="0" b="0"/>
           </a:stretch>
@@ -5580,7 +5580,7 @@
           <p:nvPr/>
         </p:nvPicPr>
         <p:blipFill>
-          <a:blip xmlns:r="http://schemas.openxmlformats.org/officeDocument/2006/relationships" xmlns:a="http://schemas.openxmlformats.org/drawingml/2006/main" r:embed="Rb9ebeb9924354980"/>
+          <a:blip xmlns:r="http://schemas.openxmlformats.org/officeDocument/2006/relationships" xmlns:a="http://schemas.openxmlformats.org/drawingml/2006/main" r:embed="R060216353a644f51"/>
           <a:stretch xmlns:a="http://schemas.openxmlformats.org/drawingml/2006/main">
             <a:fillRect l="0" t="0" r="0" b="0"/>
           </a:stretch>
@@ -5604,7 +5604,7 @@
           <p:nvPr/>
         </p:nvPicPr>
         <p:blipFill>
-          <a:blip xmlns:r="http://schemas.openxmlformats.org/officeDocument/2006/relationships" xmlns:a="http://schemas.openxmlformats.org/drawingml/2006/main" r:embed="R53e28a832c364d1d"/>
+          <a:blip xmlns:r="http://schemas.openxmlformats.org/officeDocument/2006/relationships" xmlns:a="http://schemas.openxmlformats.org/drawingml/2006/main" r:embed="R24b509845d934068"/>
           <a:stretch xmlns:a="http://schemas.openxmlformats.org/drawingml/2006/main">
             <a:fillRect l="0" t="0" r="0" b="0"/>
           </a:stretch>
@@ -6513,7 +6513,7 @@
           <p:nvPr/>
         </p:nvPicPr>
         <p:blipFill>
-          <a:blip xmlns:r="http://schemas.openxmlformats.org/officeDocument/2006/relationships" xmlns:a="http://schemas.openxmlformats.org/drawingml/2006/main" r:embed="Rd7012054eaff45ae"/>
+          <a:blip xmlns:r="http://schemas.openxmlformats.org/officeDocument/2006/relationships" xmlns:a="http://schemas.openxmlformats.org/drawingml/2006/main" r:embed="Raea033abd5b44e48"/>
           <a:stretch xmlns:a="http://schemas.openxmlformats.org/drawingml/2006/main">
             <a:fillRect l="0" t="0" r="0" b="0"/>
           </a:stretch>
@@ -6537,7 +6537,7 @@
           <p:nvPr/>
         </p:nvPicPr>
         <p:blipFill>
-          <a:blip xmlns:r="http://schemas.openxmlformats.org/officeDocument/2006/relationships" xmlns:a="http://schemas.openxmlformats.org/drawingml/2006/main" r:embed="Ra65d6628b2e0472f"/>
+          <a:blip xmlns:r="http://schemas.openxmlformats.org/officeDocument/2006/relationships" xmlns:a="http://schemas.openxmlformats.org/drawingml/2006/main" r:embed="R4134999cd59c45e6"/>
           <a:stretch xmlns:a="http://schemas.openxmlformats.org/drawingml/2006/main">
             <a:fillRect l="0" t="0" r="0" b="0"/>
           </a:stretch>
@@ -6802,7 +6802,7 @@
           <p:nvPr/>
         </p:nvPicPr>
         <p:blipFill>
-          <a:blip xmlns:r="http://schemas.openxmlformats.org/officeDocument/2006/relationships" xmlns:a="http://schemas.openxmlformats.org/drawingml/2006/main" r:embed="Raaf3735faab5408c"/>
+          <a:blip xmlns:r="http://schemas.openxmlformats.org/officeDocument/2006/relationships" xmlns:a="http://schemas.openxmlformats.org/drawingml/2006/main" r:embed="R59da2904db9f4b17"/>
           <a:stretch xmlns:a="http://schemas.openxmlformats.org/drawingml/2006/main">
             <a:fillRect l="0" t="0" r="0" b="0"/>
           </a:stretch>
@@ -6872,7 +6872,7 @@
           <p:nvPr/>
         </p:nvPicPr>
         <p:blipFill>
-          <a:blip xmlns:r="http://schemas.openxmlformats.org/officeDocument/2006/relationships" xmlns:a="http://schemas.openxmlformats.org/drawingml/2006/main" r:embed="Rd85539089289444e"/>
+          <a:blip xmlns:r="http://schemas.openxmlformats.org/officeDocument/2006/relationships" xmlns:a="http://schemas.openxmlformats.org/drawingml/2006/main" r:embed="R6002f7aea836412c"/>
           <a:stretch xmlns:a="http://schemas.openxmlformats.org/drawingml/2006/main">
             <a:fillRect l="0" t="0" r="0" b="0"/>
           </a:stretch>
@@ -6942,7 +6942,7 @@
           <p:nvPr/>
         </p:nvPicPr>
         <p:blipFill>
-          <a:blip xmlns:r="http://schemas.openxmlformats.org/officeDocument/2006/relationships" xmlns:a="http://schemas.openxmlformats.org/drawingml/2006/main" r:embed="R0e9f7d3684ef4718"/>
+          <a:blip xmlns:r="http://schemas.openxmlformats.org/officeDocument/2006/relationships" xmlns:a="http://schemas.openxmlformats.org/drawingml/2006/main" r:embed="R6509619467cf4767"/>
           <a:stretch xmlns:a="http://schemas.openxmlformats.org/drawingml/2006/main">
             <a:fillRect l="0" t="0" r="0" b="0"/>
           </a:stretch>
@@ -6997,7 +6997,7 @@
                 <a:ea typeface="Calibri"/>
                 <a:cs typeface="Calibri"/>
               </a:rPr>
-              <a:t>Kumpulkan observations.jsonl</a:t>
+              <a:t>Catat observations.jsonl</a:t>
             </a:r>
             <a:endParaRPr sz="1600"/>
           </a:p>
@@ -7012,7 +7012,7 @@
           <p:nvPr/>
         </p:nvPicPr>
         <p:blipFill>
-          <a:blip xmlns:r="http://schemas.openxmlformats.org/officeDocument/2006/relationships" xmlns:a="http://schemas.openxmlformats.org/drawingml/2006/main" r:embed="R1de3ce80e41040e4"/>
+          <a:blip xmlns:r="http://schemas.openxmlformats.org/officeDocument/2006/relationships" xmlns:a="http://schemas.openxmlformats.org/drawingml/2006/main" r:embed="Re376e0e25eaa42d0"/>
           <a:stretch xmlns:a="http://schemas.openxmlformats.org/drawingml/2006/main">
             <a:fillRect l="0" t="0" r="0" b="0"/>
           </a:stretch>
@@ -7082,7 +7082,7 @@
           <p:nvPr/>
         </p:nvPicPr>
         <p:blipFill>
-          <a:blip xmlns:r="http://schemas.openxmlformats.org/officeDocument/2006/relationships" xmlns:a="http://schemas.openxmlformats.org/drawingml/2006/main" r:embed="R7c7ebe8049784567"/>
+          <a:blip xmlns:r="http://schemas.openxmlformats.org/officeDocument/2006/relationships" xmlns:a="http://schemas.openxmlformats.org/drawingml/2006/main" r:embed="R1b4f3cf57bc242c0"/>
           <a:stretch xmlns:a="http://schemas.openxmlformats.org/drawingml/2006/main">
             <a:fillRect l="0" t="0" r="0" b="0"/>
           </a:stretch>
@@ -7152,7 +7152,7 @@
           <p:nvPr/>
         </p:nvPicPr>
         <p:blipFill>
-          <a:blip xmlns:r="http://schemas.openxmlformats.org/officeDocument/2006/relationships" xmlns:a="http://schemas.openxmlformats.org/drawingml/2006/main" r:embed="R343af74831f4449e"/>
+          <a:blip xmlns:r="http://schemas.openxmlformats.org/officeDocument/2006/relationships" xmlns:a="http://schemas.openxmlformats.org/drawingml/2006/main" r:embed="R59889345855a4e03"/>
           <a:stretch xmlns:a="http://schemas.openxmlformats.org/drawingml/2006/main">
             <a:fillRect l="0" t="0" r="0" b="0"/>
           </a:stretch>
@@ -7222,7 +7222,7 @@
           <p:nvPr/>
         </p:nvPicPr>
         <p:blipFill>
-          <a:blip xmlns:r="http://schemas.openxmlformats.org/officeDocument/2006/relationships" xmlns:a="http://schemas.openxmlformats.org/drawingml/2006/main" r:embed="R3b04f2f463ab4751"/>
+          <a:blip xmlns:r="http://schemas.openxmlformats.org/officeDocument/2006/relationships" xmlns:a="http://schemas.openxmlformats.org/drawingml/2006/main" r:embed="Rec792d8d25c14de7"/>
           <a:stretch xmlns:a="http://schemas.openxmlformats.org/drawingml/2006/main">
             <a:fillRect l="0" t="0" r="0" b="0"/>
           </a:stretch>
@@ -7361,7 +7361,7 @@
                 <a:ea typeface="Calibri"/>
                 <a:cs typeface="Calibri"/>
               </a:rPr>
-              <a:t>BUKTI YANG DIKUMPULKAN</a:t>
+              <a:t>PROYEK KELOMPOK</a:t>
             </a:r>
           </a:p>
           <a:p xmlns:a="http://schemas.openxmlformats.org/drawingml/2006/main">
@@ -7390,7 +7390,7 @@
                 <a:ea typeface="Calibri"/>
                 <a:cs typeface="Calibri"/>
               </a:rPr>
-              <a:t>Hasil mesin sendiri</a:t>
+              <a:t>Tim 3 orang</a:t>
             </a:r>
             <a:endParaRPr sz="1100"/>
           </a:p>
@@ -7439,7 +7439,7 @@
                 <a:ea typeface="Calibri"/>
                 <a:cs typeface="Calibri"/>
               </a:rPr>
-              <a:t>1. JSONL probe tiga target</a:t>
+              <a:t>Monitoring mendukung operasi proyek</a:t>
             </a:r>
           </a:p>
           <a:p xmlns:a="http://schemas.openxmlformats.org/drawingml/2006/main">
@@ -7458,7 +7458,7 @@
                 <a:ea typeface="Calibri"/>
                 <a:cs typeface="Calibri"/>
               </a:rPr>
-              <a:t>2. p95 dan availability sampel</a:t>
+              <a:t>Ukur availability dan p95 sampel</a:t>
             </a:r>
           </a:p>
           <a:p xmlns:a="http://schemas.openxmlformats.org/drawingml/2006/main">
@@ -7477,7 +7477,7 @@
                 <a:ea typeface="Calibri"/>
                 <a:cs typeface="Calibri"/>
               </a:rPr>
-              <a:t>3. Halaman UP lalu DOWN</a:t>
+              <a:t>Simpan bukti bila berguna</a:t>
             </a:r>
           </a:p>
           <a:p xmlns:a="http://schemas.openxmlformats.org/drawingml/2006/main">
@@ -7496,7 +7496,7 @@
                 <a:ea typeface="Calibri"/>
                 <a:cs typeface="Calibri"/>
               </a:rPr>
-              <a:t>4. Log JSON dan penjelasan budget</a:t>
+              <a:t>Minggu 7 dan 14; tanpa nilai Lab 10</a:t>
             </a:r>
             <a:endParaRPr sz="1700"/>
           </a:p>
@@ -7754,7 +7754,7 @@
           <p:nvPr/>
         </p:nvPicPr>
         <p:blipFill>
-          <a:blip xmlns:r="http://schemas.openxmlformats.org/officeDocument/2006/relationships" xmlns:a="http://schemas.openxmlformats.org/drawingml/2006/main" r:embed="Rb64af87e4c7846af"/>
+          <a:blip xmlns:r="http://schemas.openxmlformats.org/officeDocument/2006/relationships" xmlns:a="http://schemas.openxmlformats.org/drawingml/2006/main" r:embed="R0e9dcc0ff9c645ed"/>
           <a:stretch xmlns:a="http://schemas.openxmlformats.org/drawingml/2006/main">
             <a:fillRect l="0" t="0" r="0" b="0"/>
           </a:stretch>
@@ -7778,7 +7778,7 @@
           <p:nvPr/>
         </p:nvPicPr>
         <p:blipFill>
-          <a:blip xmlns:r="http://schemas.openxmlformats.org/officeDocument/2006/relationships" xmlns:a="http://schemas.openxmlformats.org/drawingml/2006/main" r:embed="R07d51711e2f5477f"/>
+          <a:blip xmlns:r="http://schemas.openxmlformats.org/officeDocument/2006/relationships" xmlns:a="http://schemas.openxmlformats.org/drawingml/2006/main" r:embed="R2a3c3e0c9d3245a6"/>
           <a:stretch xmlns:a="http://schemas.openxmlformats.org/drawingml/2006/main">
             <a:fillRect l="0" t="0" r="0" b="0"/>
           </a:stretch>
@@ -8683,7 +8683,7 @@
           <p:nvPr/>
         </p:nvPicPr>
         <p:blipFill>
-          <a:blip xmlns:r="http://schemas.openxmlformats.org/officeDocument/2006/relationships" xmlns:a="http://schemas.openxmlformats.org/drawingml/2006/main" r:embed="Rdadf905bb6834a1c"/>
+          <a:blip xmlns:r="http://schemas.openxmlformats.org/officeDocument/2006/relationships" xmlns:a="http://schemas.openxmlformats.org/drawingml/2006/main" r:embed="R693366f6c68b4ef9"/>
           <a:stretch xmlns:a="http://schemas.openxmlformats.org/drawingml/2006/main">
             <a:fillRect l="0" t="0" r="0" b="0"/>
           </a:stretch>
@@ -8707,7 +8707,7 @@
           <p:nvPr/>
         </p:nvPicPr>
         <p:blipFill>
-          <a:blip xmlns:r="http://schemas.openxmlformats.org/officeDocument/2006/relationships" xmlns:a="http://schemas.openxmlformats.org/drawingml/2006/main" r:embed="R6eb390e7a47744ef"/>
+          <a:blip xmlns:r="http://schemas.openxmlformats.org/officeDocument/2006/relationships" xmlns:a="http://schemas.openxmlformats.org/drawingml/2006/main" r:embed="Rc7bbffc24a7348be"/>
           <a:stretch xmlns:a="http://schemas.openxmlformats.org/drawingml/2006/main">
             <a:fillRect l="0" t="0" r="0" b="0"/>
           </a:stretch>
@@ -9611,7 +9611,7 @@
           <p:nvPr/>
         </p:nvPicPr>
         <p:blipFill>
-          <a:blip xmlns:r="http://schemas.openxmlformats.org/officeDocument/2006/relationships" xmlns:a="http://schemas.openxmlformats.org/drawingml/2006/main" r:embed="Ra293e282825b4037"/>
+          <a:blip xmlns:r="http://schemas.openxmlformats.org/officeDocument/2006/relationships" xmlns:a="http://schemas.openxmlformats.org/drawingml/2006/main" r:embed="R9cccd0a95df44476"/>
           <a:stretch xmlns:a="http://schemas.openxmlformats.org/drawingml/2006/main">
             <a:fillRect l="0" t="0" r="0" b="0"/>
           </a:stretch>
@@ -9635,7 +9635,7 @@
           <p:nvPr/>
         </p:nvPicPr>
         <p:blipFill>
-          <a:blip xmlns:r="http://schemas.openxmlformats.org/officeDocument/2006/relationships" xmlns:a="http://schemas.openxmlformats.org/drawingml/2006/main" r:embed="Raa2c68380a384c8c"/>
+          <a:blip xmlns:r="http://schemas.openxmlformats.org/officeDocument/2006/relationships" xmlns:a="http://schemas.openxmlformats.org/drawingml/2006/main" r:embed="R995ed0db673e4cfa"/>
           <a:stretch xmlns:a="http://schemas.openxmlformats.org/drawingml/2006/main">
             <a:fillRect l="0" t="0" r="0" b="0"/>
           </a:stretch>
@@ -9871,7 +9871,7 @@
           <p:nvPr/>
         </p:nvPicPr>
         <p:blipFill>
-          <a:blip xmlns:r="http://schemas.openxmlformats.org/officeDocument/2006/relationships" xmlns:a="http://schemas.openxmlformats.org/drawingml/2006/main" r:embed="R90fd7590ee4d4ab6"/>
+          <a:blip xmlns:r="http://schemas.openxmlformats.org/officeDocument/2006/relationships" xmlns:a="http://schemas.openxmlformats.org/drawingml/2006/main" r:embed="Rf81acab152b54ff6"/>
           <a:stretch xmlns:a="http://schemas.openxmlformats.org/drawingml/2006/main">
             <a:fillRect l="0" t="0" r="0" b="0"/>
           </a:stretch>
@@ -9948,7 +9948,7 @@
           <p:nvPr/>
         </p:nvPicPr>
         <p:blipFill>
-          <a:blip xmlns:r="http://schemas.openxmlformats.org/officeDocument/2006/relationships" xmlns:a="http://schemas.openxmlformats.org/drawingml/2006/main" r:embed="R3b129a2cfa2e4ef1"/>
+          <a:blip xmlns:r="http://schemas.openxmlformats.org/officeDocument/2006/relationships" xmlns:a="http://schemas.openxmlformats.org/drawingml/2006/main" r:embed="R059d22f32cd34f7a"/>
           <a:stretch xmlns:a="http://schemas.openxmlformats.org/drawingml/2006/main">
             <a:fillRect l="0" t="0" r="0" b="0"/>
           </a:stretch>
@@ -10025,7 +10025,7 @@
           <p:nvPr/>
         </p:nvPicPr>
         <p:blipFill>
-          <a:blip xmlns:r="http://schemas.openxmlformats.org/officeDocument/2006/relationships" xmlns:a="http://schemas.openxmlformats.org/drawingml/2006/main" r:embed="R52170f8dec824fdf"/>
+          <a:blip xmlns:r="http://schemas.openxmlformats.org/officeDocument/2006/relationships" xmlns:a="http://schemas.openxmlformats.org/drawingml/2006/main" r:embed="R3e3b959150b54db5"/>
           <a:stretch xmlns:a="http://schemas.openxmlformats.org/drawingml/2006/main">
             <a:fillRect l="0" t="0" r="0" b="0"/>
           </a:stretch>
@@ -10102,7 +10102,7 @@
           <p:nvPr/>
         </p:nvPicPr>
         <p:blipFill>
-          <a:blip xmlns:r="http://schemas.openxmlformats.org/officeDocument/2006/relationships" xmlns:a="http://schemas.openxmlformats.org/drawingml/2006/main" r:embed="R6643ec78a04e46be"/>
+          <a:blip xmlns:r="http://schemas.openxmlformats.org/officeDocument/2006/relationships" xmlns:a="http://schemas.openxmlformats.org/drawingml/2006/main" r:embed="R982dd6058d3140c3"/>
           <a:stretch xmlns:a="http://schemas.openxmlformats.org/drawingml/2006/main">
             <a:fillRect l="0" t="0" r="0" b="0"/>
           </a:stretch>
@@ -10179,7 +10179,7 @@
           <p:nvPr/>
         </p:nvPicPr>
         <p:blipFill>
-          <a:blip xmlns:r="http://schemas.openxmlformats.org/officeDocument/2006/relationships" xmlns:a="http://schemas.openxmlformats.org/drawingml/2006/main" r:embed="R5a68299579754b18"/>
+          <a:blip xmlns:r="http://schemas.openxmlformats.org/officeDocument/2006/relationships" xmlns:a="http://schemas.openxmlformats.org/drawingml/2006/main" r:embed="R55415ba6ca674de4"/>
           <a:stretch xmlns:a="http://schemas.openxmlformats.org/drawingml/2006/main">
             <a:fillRect l="0" t="0" r="0" b="0"/>
           </a:stretch>
@@ -10256,7 +10256,7 @@
           <p:nvPr/>
         </p:nvPicPr>
         <p:blipFill>
-          <a:blip xmlns:r="http://schemas.openxmlformats.org/officeDocument/2006/relationships" xmlns:a="http://schemas.openxmlformats.org/drawingml/2006/main" r:embed="Rc87fb62c947d418a"/>
+          <a:blip xmlns:r="http://schemas.openxmlformats.org/officeDocument/2006/relationships" xmlns:a="http://schemas.openxmlformats.org/drawingml/2006/main" r:embed="R6cd3d550f6924690"/>
           <a:stretch xmlns:a="http://schemas.openxmlformats.org/drawingml/2006/main">
             <a:fillRect l="0" t="0" r="0" b="0"/>
           </a:stretch>
@@ -10333,7 +10333,7 @@
           <p:nvPr/>
         </p:nvPicPr>
         <p:blipFill>
-          <a:blip xmlns:r="http://schemas.openxmlformats.org/officeDocument/2006/relationships" xmlns:a="http://schemas.openxmlformats.org/drawingml/2006/main" r:embed="Rfc3423cdf5d64877"/>
+          <a:blip xmlns:r="http://schemas.openxmlformats.org/officeDocument/2006/relationships" xmlns:a="http://schemas.openxmlformats.org/drawingml/2006/main" r:embed="Rfe688806424d47c4"/>
           <a:stretch xmlns:a="http://schemas.openxmlformats.org/drawingml/2006/main">
             <a:fillRect l="0" t="0" r="0" b="0"/>
           </a:stretch>
@@ -10623,7 +10623,7 @@
           <p:nvPr/>
         </p:nvPicPr>
         <p:blipFill>
-          <a:blip xmlns:r="http://schemas.openxmlformats.org/officeDocument/2006/relationships" xmlns:a="http://schemas.openxmlformats.org/drawingml/2006/main" r:embed="R249765bbf02f4c5b"/>
+          <a:blip xmlns:r="http://schemas.openxmlformats.org/officeDocument/2006/relationships" xmlns:a="http://schemas.openxmlformats.org/drawingml/2006/main" r:embed="R02f68bbc8fdf454b"/>
           <a:stretch xmlns:a="http://schemas.openxmlformats.org/drawingml/2006/main">
             <a:fillRect l="0" t="0" r="0" b="0"/>
           </a:stretch>
@@ -10806,7 +10806,7 @@
           <p:nvPr/>
         </p:nvPicPr>
         <p:blipFill>
-          <a:blip xmlns:r="http://schemas.openxmlformats.org/officeDocument/2006/relationships" xmlns:a="http://schemas.openxmlformats.org/drawingml/2006/main" r:embed="R34a2c891ec0746ad"/>
+          <a:blip xmlns:r="http://schemas.openxmlformats.org/officeDocument/2006/relationships" xmlns:a="http://schemas.openxmlformats.org/drawingml/2006/main" r:embed="R1613b812509b4ed4"/>
           <a:stretch xmlns:a="http://schemas.openxmlformats.org/drawingml/2006/main">
             <a:fillRect l="0" t="0" r="0" b="0"/>
           </a:stretch>
@@ -10830,7 +10830,7 @@
           <p:nvPr/>
         </p:nvPicPr>
         <p:blipFill>
-          <a:blip xmlns:r="http://schemas.openxmlformats.org/officeDocument/2006/relationships" xmlns:a="http://schemas.openxmlformats.org/drawingml/2006/main" r:embed="R2ccd122851d44772"/>
+          <a:blip xmlns:r="http://schemas.openxmlformats.org/officeDocument/2006/relationships" xmlns:a="http://schemas.openxmlformats.org/drawingml/2006/main" r:embed="R63bc984a80b84be0"/>
           <a:stretch xmlns:a="http://schemas.openxmlformats.org/drawingml/2006/main">
             <a:fillRect l="0" t="0" r="0" b="0"/>
           </a:stretch>
@@ -11066,7 +11066,7 @@
           <p:nvPr/>
         </p:nvPicPr>
         <p:blipFill>
-          <a:blip xmlns:r="http://schemas.openxmlformats.org/officeDocument/2006/relationships" xmlns:a="http://schemas.openxmlformats.org/drawingml/2006/main" r:embed="R9e585eaec41c4c43"/>
+          <a:blip xmlns:r="http://schemas.openxmlformats.org/officeDocument/2006/relationships" xmlns:a="http://schemas.openxmlformats.org/drawingml/2006/main" r:embed="R67c73ffdd2fa4a01"/>
           <a:stretch xmlns:a="http://schemas.openxmlformats.org/drawingml/2006/main">
             <a:fillRect l="0" t="0" r="0" b="0"/>
           </a:stretch>
@@ -11143,7 +11143,7 @@
           <p:nvPr/>
         </p:nvPicPr>
         <p:blipFill>
-          <a:blip xmlns:r="http://schemas.openxmlformats.org/officeDocument/2006/relationships" xmlns:a="http://schemas.openxmlformats.org/drawingml/2006/main" r:embed="R4984f687563d4268"/>
+          <a:blip xmlns:r="http://schemas.openxmlformats.org/officeDocument/2006/relationships" xmlns:a="http://schemas.openxmlformats.org/drawingml/2006/main" r:embed="Rd3797b3c75b9470f"/>
           <a:stretch xmlns:a="http://schemas.openxmlformats.org/drawingml/2006/main">
             <a:fillRect l="0" t="0" r="0" b="0"/>
           </a:stretch>
@@ -11220,7 +11220,7 @@
           <p:nvPr/>
         </p:nvPicPr>
         <p:blipFill>
-          <a:blip xmlns:r="http://schemas.openxmlformats.org/officeDocument/2006/relationships" xmlns:a="http://schemas.openxmlformats.org/drawingml/2006/main" r:embed="R573192de79a64d4e"/>
+          <a:blip xmlns:r="http://schemas.openxmlformats.org/officeDocument/2006/relationships" xmlns:a="http://schemas.openxmlformats.org/drawingml/2006/main" r:embed="R22997519e9964b50"/>
           <a:stretch xmlns:a="http://schemas.openxmlformats.org/drawingml/2006/main">
             <a:fillRect l="0" t="0" r="0" b="0"/>
           </a:stretch>
@@ -11297,7 +11297,7 @@
           <p:nvPr/>
         </p:nvPicPr>
         <p:blipFill>
-          <a:blip xmlns:r="http://schemas.openxmlformats.org/officeDocument/2006/relationships" xmlns:a="http://schemas.openxmlformats.org/drawingml/2006/main" r:embed="R4a0ab6552b424887"/>
+          <a:blip xmlns:r="http://schemas.openxmlformats.org/officeDocument/2006/relationships" xmlns:a="http://schemas.openxmlformats.org/drawingml/2006/main" r:embed="Ree20e61ce311444e"/>
           <a:stretch xmlns:a="http://schemas.openxmlformats.org/drawingml/2006/main">
             <a:fillRect l="0" t="0" r="0" b="0"/>
           </a:stretch>
@@ -11374,7 +11374,7 @@
           <p:nvPr/>
         </p:nvPicPr>
         <p:blipFill>
-          <a:blip xmlns:r="http://schemas.openxmlformats.org/officeDocument/2006/relationships" xmlns:a="http://schemas.openxmlformats.org/drawingml/2006/main" r:embed="R9f7629623ad94462"/>
+          <a:blip xmlns:r="http://schemas.openxmlformats.org/officeDocument/2006/relationships" xmlns:a="http://schemas.openxmlformats.org/drawingml/2006/main" r:embed="Rfa6a1d0c5dbe4822"/>
           <a:stretch xmlns:a="http://schemas.openxmlformats.org/drawingml/2006/main">
             <a:fillRect l="0" t="0" r="0" b="0"/>
           </a:stretch>
@@ -11451,7 +11451,7 @@
           <p:nvPr/>
         </p:nvPicPr>
         <p:blipFill>
-          <a:blip xmlns:r="http://schemas.openxmlformats.org/officeDocument/2006/relationships" xmlns:a="http://schemas.openxmlformats.org/drawingml/2006/main" r:embed="Rc5606a45a69c4195"/>
+          <a:blip xmlns:r="http://schemas.openxmlformats.org/officeDocument/2006/relationships" xmlns:a="http://schemas.openxmlformats.org/drawingml/2006/main" r:embed="R22afb1f8a4604feb"/>
           <a:stretch xmlns:a="http://schemas.openxmlformats.org/drawingml/2006/main">
             <a:fillRect l="0" t="0" r="0" b="0"/>
           </a:stretch>
@@ -11528,7 +11528,7 @@
           <p:nvPr/>
         </p:nvPicPr>
         <p:blipFill>
-          <a:blip xmlns:r="http://schemas.openxmlformats.org/officeDocument/2006/relationships" xmlns:a="http://schemas.openxmlformats.org/drawingml/2006/main" r:embed="R481f3051ddc443e3"/>
+          <a:blip xmlns:r="http://schemas.openxmlformats.org/officeDocument/2006/relationships" xmlns:a="http://schemas.openxmlformats.org/drawingml/2006/main" r:embed="Rd5c632f337b4442b"/>
           <a:stretch xmlns:a="http://schemas.openxmlformats.org/drawingml/2006/main">
             <a:fillRect l="0" t="0" r="0" b="0"/>
           </a:stretch>
@@ -11818,7 +11818,7 @@
           <p:nvPr/>
         </p:nvPicPr>
         <p:blipFill>
-          <a:blip xmlns:r="http://schemas.openxmlformats.org/officeDocument/2006/relationships" xmlns:a="http://schemas.openxmlformats.org/drawingml/2006/main" r:embed="Rd04e1e850dc447ce"/>
+          <a:blip xmlns:r="http://schemas.openxmlformats.org/officeDocument/2006/relationships" xmlns:a="http://schemas.openxmlformats.org/drawingml/2006/main" r:embed="R635a8ab304ec4363"/>
           <a:stretch xmlns:a="http://schemas.openxmlformats.org/drawingml/2006/main">
             <a:fillRect l="0" t="0" r="0" b="0"/>
           </a:stretch>
@@ -12001,7 +12001,7 @@
           <p:nvPr/>
         </p:nvPicPr>
         <p:blipFill>
-          <a:blip xmlns:r="http://schemas.openxmlformats.org/officeDocument/2006/relationships" xmlns:a="http://schemas.openxmlformats.org/drawingml/2006/main" r:embed="R36381ab52e854370"/>
+          <a:blip xmlns:r="http://schemas.openxmlformats.org/officeDocument/2006/relationships" xmlns:a="http://schemas.openxmlformats.org/drawingml/2006/main" r:embed="Rb4054540f1f84282"/>
           <a:stretch xmlns:a="http://schemas.openxmlformats.org/drawingml/2006/main">
             <a:fillRect l="0" t="0" r="0" b="0"/>
           </a:stretch>
@@ -12025,7 +12025,7 @@
           <p:nvPr/>
         </p:nvPicPr>
         <p:blipFill>
-          <a:blip xmlns:r="http://schemas.openxmlformats.org/officeDocument/2006/relationships" xmlns:a="http://schemas.openxmlformats.org/drawingml/2006/main" r:embed="R7d5731de99d747a4"/>
+          <a:blip xmlns:r="http://schemas.openxmlformats.org/officeDocument/2006/relationships" xmlns:a="http://schemas.openxmlformats.org/drawingml/2006/main" r:embed="Rbdf46a2967a64f01"/>
           <a:stretch xmlns:a="http://schemas.openxmlformats.org/drawingml/2006/main">
             <a:fillRect l="0" t="0" r="0" b="0"/>
           </a:stretch>
@@ -12931,7 +12931,7 @@
           <p:nvPr/>
         </p:nvPicPr>
         <p:blipFill>
-          <a:blip xmlns:r="http://schemas.openxmlformats.org/officeDocument/2006/relationships" xmlns:a="http://schemas.openxmlformats.org/drawingml/2006/main" r:embed="R4319367f42dc4db6"/>
+          <a:blip xmlns:r="http://schemas.openxmlformats.org/officeDocument/2006/relationships" xmlns:a="http://schemas.openxmlformats.org/drawingml/2006/main" r:embed="R4bcd9496ab0042d1"/>
           <a:stretch xmlns:a="http://schemas.openxmlformats.org/drawingml/2006/main">
             <a:fillRect l="0" t="0" r="0" b="0"/>
           </a:stretch>
@@ -12955,7 +12955,7 @@
           <p:nvPr/>
         </p:nvPicPr>
         <p:blipFill>
-          <a:blip xmlns:r="http://schemas.openxmlformats.org/officeDocument/2006/relationships" xmlns:a="http://schemas.openxmlformats.org/drawingml/2006/main" r:embed="Re80e1cdd81b6465b"/>
+          <a:blip xmlns:r="http://schemas.openxmlformats.org/officeDocument/2006/relationships" xmlns:a="http://schemas.openxmlformats.org/drawingml/2006/main" r:embed="R6ec9e7f19b374f9b"/>
           <a:stretch xmlns:a="http://schemas.openxmlformats.org/drawingml/2006/main">
             <a:fillRect l="0" t="0" r="0" b="0"/>
           </a:stretch>
@@ -13191,7 +13191,7 @@
           <p:nvPr/>
         </p:nvPicPr>
         <p:blipFill>
-          <a:blip xmlns:r="http://schemas.openxmlformats.org/officeDocument/2006/relationships" xmlns:a="http://schemas.openxmlformats.org/drawingml/2006/main" r:embed="R37a10a6de71d4b97"/>
+          <a:blip xmlns:r="http://schemas.openxmlformats.org/officeDocument/2006/relationships" xmlns:a="http://schemas.openxmlformats.org/drawingml/2006/main" r:embed="R4f02e08312e445c1"/>
           <a:stretch xmlns:a="http://schemas.openxmlformats.org/drawingml/2006/main">
             <a:fillRect l="0" t="0" r="0" b="0"/>
           </a:stretch>
@@ -13268,7 +13268,7 @@
           <p:nvPr/>
         </p:nvPicPr>
         <p:blipFill>
-          <a:blip xmlns:r="http://schemas.openxmlformats.org/officeDocument/2006/relationships" xmlns:a="http://schemas.openxmlformats.org/drawingml/2006/main" r:embed="R45f9188d9cef4fdb"/>
+          <a:blip xmlns:r="http://schemas.openxmlformats.org/officeDocument/2006/relationships" xmlns:a="http://schemas.openxmlformats.org/drawingml/2006/main" r:embed="R201811c2d3ef41ac"/>
           <a:stretch xmlns:a="http://schemas.openxmlformats.org/drawingml/2006/main">
             <a:fillRect l="0" t="0" r="0" b="0"/>
           </a:stretch>
@@ -13345,7 +13345,7 @@
           <p:nvPr/>
         </p:nvPicPr>
         <p:blipFill>
-          <a:blip xmlns:r="http://schemas.openxmlformats.org/officeDocument/2006/relationships" xmlns:a="http://schemas.openxmlformats.org/drawingml/2006/main" r:embed="R85f1c69735234cc5"/>
+          <a:blip xmlns:r="http://schemas.openxmlformats.org/officeDocument/2006/relationships" xmlns:a="http://schemas.openxmlformats.org/drawingml/2006/main" r:embed="R5cdb6813e5f54e12"/>
           <a:stretch xmlns:a="http://schemas.openxmlformats.org/drawingml/2006/main">
             <a:fillRect l="0" t="0" r="0" b="0"/>
           </a:stretch>
@@ -13422,7 +13422,7 @@
           <p:nvPr/>
         </p:nvPicPr>
         <p:blipFill>
-          <a:blip xmlns:r="http://schemas.openxmlformats.org/officeDocument/2006/relationships" xmlns:a="http://schemas.openxmlformats.org/drawingml/2006/main" r:embed="R520693d00958422d"/>
+          <a:blip xmlns:r="http://schemas.openxmlformats.org/officeDocument/2006/relationships" xmlns:a="http://schemas.openxmlformats.org/drawingml/2006/main" r:embed="Rc5823297ec894904"/>
           <a:stretch xmlns:a="http://schemas.openxmlformats.org/drawingml/2006/main">
             <a:fillRect l="0" t="0" r="0" b="0"/>
           </a:stretch>
@@ -13499,7 +13499,7 @@
           <p:nvPr/>
         </p:nvPicPr>
         <p:blipFill>
-          <a:blip xmlns:r="http://schemas.openxmlformats.org/officeDocument/2006/relationships" xmlns:a="http://schemas.openxmlformats.org/drawingml/2006/main" r:embed="Ra7847d0c63084abb"/>
+          <a:blip xmlns:r="http://schemas.openxmlformats.org/officeDocument/2006/relationships" xmlns:a="http://schemas.openxmlformats.org/drawingml/2006/main" r:embed="R645e6e78253840e8"/>
           <a:stretch xmlns:a="http://schemas.openxmlformats.org/drawingml/2006/main">
             <a:fillRect l="0" t="0" r="0" b="0"/>
           </a:stretch>
@@ -13576,7 +13576,7 @@
           <p:nvPr/>
         </p:nvPicPr>
         <p:blipFill>
-          <a:blip xmlns:r="http://schemas.openxmlformats.org/officeDocument/2006/relationships" xmlns:a="http://schemas.openxmlformats.org/drawingml/2006/main" r:embed="Re6cbf72364ea47e8"/>
+          <a:blip xmlns:r="http://schemas.openxmlformats.org/officeDocument/2006/relationships" xmlns:a="http://schemas.openxmlformats.org/drawingml/2006/main" r:embed="R7a69adbb90214b9d"/>
           <a:stretch xmlns:a="http://schemas.openxmlformats.org/drawingml/2006/main">
             <a:fillRect l="0" t="0" r="0" b="0"/>
           </a:stretch>
@@ -13653,7 +13653,7 @@
           <p:nvPr/>
         </p:nvPicPr>
         <p:blipFill>
-          <a:blip xmlns:r="http://schemas.openxmlformats.org/officeDocument/2006/relationships" xmlns:a="http://schemas.openxmlformats.org/drawingml/2006/main" r:embed="R631227964b0e4082"/>
+          <a:blip xmlns:r="http://schemas.openxmlformats.org/officeDocument/2006/relationships" xmlns:a="http://schemas.openxmlformats.org/drawingml/2006/main" r:embed="R6f1158a341844565"/>
           <a:stretch xmlns:a="http://schemas.openxmlformats.org/drawingml/2006/main">
             <a:fillRect l="0" t="0" r="0" b="0"/>
           </a:stretch>
@@ -13943,7 +13943,7 @@
           <p:nvPr/>
         </p:nvPicPr>
         <p:blipFill>
-          <a:blip xmlns:r="http://schemas.openxmlformats.org/officeDocument/2006/relationships" xmlns:a="http://schemas.openxmlformats.org/drawingml/2006/main" r:embed="R483718084f884842"/>
+          <a:blip xmlns:r="http://schemas.openxmlformats.org/officeDocument/2006/relationships" xmlns:a="http://schemas.openxmlformats.org/drawingml/2006/main" r:embed="R60ff8757820340fa"/>
           <a:stretch xmlns:a="http://schemas.openxmlformats.org/drawingml/2006/main">
             <a:fillRect l="0" t="0" r="0" b="0"/>
           </a:stretch>
@@ -14119,7 +14119,7 @@
           <p:nvPr/>
         </p:nvPicPr>
         <p:blipFill>
-          <a:blip xmlns:r="http://schemas.openxmlformats.org/officeDocument/2006/relationships" xmlns:a="http://schemas.openxmlformats.org/drawingml/2006/main" r:embed="Re061981f59784777"/>
+          <a:blip xmlns:r="http://schemas.openxmlformats.org/officeDocument/2006/relationships" xmlns:a="http://schemas.openxmlformats.org/drawingml/2006/main" r:embed="R043303fa26af4359"/>
           <a:stretch xmlns:a="http://schemas.openxmlformats.org/drawingml/2006/main">
             <a:fillRect l="0" t="0" r="0" b="0"/>
           </a:stretch>
@@ -14143,7 +14143,7 @@
           <p:nvPr/>
         </p:nvPicPr>
         <p:blipFill>
-          <a:blip xmlns:r="http://schemas.openxmlformats.org/officeDocument/2006/relationships" xmlns:a="http://schemas.openxmlformats.org/drawingml/2006/main" r:embed="Re3e6cb4869a345bf"/>
+          <a:blip xmlns:r="http://schemas.openxmlformats.org/officeDocument/2006/relationships" xmlns:a="http://schemas.openxmlformats.org/drawingml/2006/main" r:embed="R211141b2bac340fe"/>
           <a:stretch xmlns:a="http://schemas.openxmlformats.org/drawingml/2006/main">
             <a:fillRect l="0" t="0" r="0" b="0"/>
           </a:stretch>
@@ -14379,7 +14379,7 @@
           <p:nvPr/>
         </p:nvPicPr>
         <p:blipFill>
-          <a:blip xmlns:r="http://schemas.openxmlformats.org/officeDocument/2006/relationships" xmlns:a="http://schemas.openxmlformats.org/drawingml/2006/main" r:embed="Rf5c4667a53214dd1"/>
+          <a:blip xmlns:r="http://schemas.openxmlformats.org/officeDocument/2006/relationships" xmlns:a="http://schemas.openxmlformats.org/drawingml/2006/main" r:embed="R075095e9ddac4543"/>
           <a:stretch xmlns:a="http://schemas.openxmlformats.org/drawingml/2006/main">
             <a:fillRect l="0" t="0" r="0" b="0"/>
           </a:stretch>
@@ -14456,7 +14456,7 @@
           <p:nvPr/>
         </p:nvPicPr>
         <p:blipFill>
-          <a:blip xmlns:r="http://schemas.openxmlformats.org/officeDocument/2006/relationships" xmlns:a="http://schemas.openxmlformats.org/drawingml/2006/main" r:embed="R74b3279763de41bb"/>
+          <a:blip xmlns:r="http://schemas.openxmlformats.org/officeDocument/2006/relationships" xmlns:a="http://schemas.openxmlformats.org/drawingml/2006/main" r:embed="R539f1ba9c7014784"/>
           <a:stretch xmlns:a="http://schemas.openxmlformats.org/drawingml/2006/main">
             <a:fillRect l="0" t="0" r="0" b="0"/>
           </a:stretch>
@@ -14533,7 +14533,7 @@
           <p:nvPr/>
         </p:nvPicPr>
         <p:blipFill>
-          <a:blip xmlns:r="http://schemas.openxmlformats.org/officeDocument/2006/relationships" xmlns:a="http://schemas.openxmlformats.org/drawingml/2006/main" r:embed="Rdfa5f1c744884e7b"/>
+          <a:blip xmlns:r="http://schemas.openxmlformats.org/officeDocument/2006/relationships" xmlns:a="http://schemas.openxmlformats.org/drawingml/2006/main" r:embed="R4d654b3e7e5a46b3"/>
           <a:stretch xmlns:a="http://schemas.openxmlformats.org/drawingml/2006/main">
             <a:fillRect l="0" t="0" r="0" b="0"/>
           </a:stretch>
@@ -14610,7 +14610,7 @@
           <p:nvPr/>
         </p:nvPicPr>
         <p:blipFill>
-          <a:blip xmlns:r="http://schemas.openxmlformats.org/officeDocument/2006/relationships" xmlns:a="http://schemas.openxmlformats.org/drawingml/2006/main" r:embed="Rb7734ffee4f84a0f"/>
+          <a:blip xmlns:r="http://schemas.openxmlformats.org/officeDocument/2006/relationships" xmlns:a="http://schemas.openxmlformats.org/drawingml/2006/main" r:embed="R6dba8dbe97154cd3"/>
           <a:stretch xmlns:a="http://schemas.openxmlformats.org/drawingml/2006/main">
             <a:fillRect l="0" t="0" r="0" b="0"/>
           </a:stretch>
@@ -14687,7 +14687,7 @@
           <p:nvPr/>
         </p:nvPicPr>
         <p:blipFill>
-          <a:blip xmlns:r="http://schemas.openxmlformats.org/officeDocument/2006/relationships" xmlns:a="http://schemas.openxmlformats.org/drawingml/2006/main" r:embed="Re422b80f798c41ca"/>
+          <a:blip xmlns:r="http://schemas.openxmlformats.org/officeDocument/2006/relationships" xmlns:a="http://schemas.openxmlformats.org/drawingml/2006/main" r:embed="R2f09e5199da24e49"/>
           <a:stretch xmlns:a="http://schemas.openxmlformats.org/drawingml/2006/main">
             <a:fillRect l="0" t="0" r="0" b="0"/>
           </a:stretch>
@@ -14764,7 +14764,7 @@
           <p:nvPr/>
         </p:nvPicPr>
         <p:blipFill>
-          <a:blip xmlns:r="http://schemas.openxmlformats.org/officeDocument/2006/relationships" xmlns:a="http://schemas.openxmlformats.org/drawingml/2006/main" r:embed="Re27a5af01b8b444e"/>
+          <a:blip xmlns:r="http://schemas.openxmlformats.org/officeDocument/2006/relationships" xmlns:a="http://schemas.openxmlformats.org/drawingml/2006/main" r:embed="Ra0385f04bc3d48c5"/>
           <a:stretch xmlns:a="http://schemas.openxmlformats.org/drawingml/2006/main">
             <a:fillRect l="0" t="0" r="0" b="0"/>
           </a:stretch>
@@ -14841,7 +14841,7 @@
           <p:nvPr/>
         </p:nvPicPr>
         <p:blipFill>
-          <a:blip xmlns:r="http://schemas.openxmlformats.org/officeDocument/2006/relationships" xmlns:a="http://schemas.openxmlformats.org/drawingml/2006/main" r:embed="R4c3457ae98a745a4"/>
+          <a:blip xmlns:r="http://schemas.openxmlformats.org/officeDocument/2006/relationships" xmlns:a="http://schemas.openxmlformats.org/drawingml/2006/main" r:embed="R61a25f26ce6146d6"/>
           <a:stretch xmlns:a="http://schemas.openxmlformats.org/drawingml/2006/main">
             <a:fillRect l="0" t="0" r="0" b="0"/>
           </a:stretch>
@@ -15131,7 +15131,7 @@
           <p:nvPr/>
         </p:nvPicPr>
         <p:blipFill>
-          <a:blip xmlns:r="http://schemas.openxmlformats.org/officeDocument/2006/relationships" xmlns:a="http://schemas.openxmlformats.org/drawingml/2006/main" r:embed="R1ef96f31d26447bc"/>
+          <a:blip xmlns:r="http://schemas.openxmlformats.org/officeDocument/2006/relationships" xmlns:a="http://schemas.openxmlformats.org/drawingml/2006/main" r:embed="R81f229507d8d44c3"/>
           <a:stretch xmlns:a="http://schemas.openxmlformats.org/drawingml/2006/main">
             <a:fillRect l="0" t="0" r="0" b="0"/>
           </a:stretch>

</xml_diff>

<commit_message>
Simplify local Lab 10 teaching flow and correct examples
</commit_message>
<xml_diff>
--- a/slides/LAB10_Monitoring_Status_Bukti_Live.pptx
+++ b/slides/LAB10_Monitoring_Status_Bukti_Live.pptx
@@ -5695,7 +5695,7 @@
                 <a:ea typeface="Calibri"/>
                 <a:cs typeface="Calibri"/>
               </a:rPr>
-              <a:t>6 | Alert opsional, recovery, dan Git</a:t>
+              <a:t>6 | Perluasan alert dan Git opsional</a:t>
             </a:r>
             <a:endParaRPr sz="2200"/>
           </a:p>
@@ -8200,12 +8200,12 @@
                 <a:ea typeface="Consolas"/>
                 <a:cs typeface="Consolas"/>
               </a:rPr>
-              <a:t># Lab 06: docker compose up --build -d
+              <a:t># Lab 06: .env siap sesuai modul Lab 06
+# docker compose up -d --build --wait
 # Lab 08: npm run dev
 # Lab 09: .\.venv\Scripts\python app.py
 Get-Content .\targets.local.json
-Invoke-WebRequest `
-  http://127.0.0.1:3000/api/health</a:t>
+Invoke-RestMethod http://127.0.0.1:18006/health</a:t>
             </a:r>
             <a:endParaRPr sz="1500">
               <a:solidFill>
@@ -8498,11 +8498,11 @@
                 <a:cs typeface="Aptos"/>
               </a:rPr>
               <a:t>Next.js: port 3000 /api/health.
-API Compose: port 8000 /health.
+API Compose: port 18006 /health.
 Gradio: halaman web port 7860.
 monitor.py membaca target JSON.
 URL tidak boleh berisi credential.
-Ketiga proses harus hidup saat uji UP.</a:t>
+Ketiga proses hidup untuk baseline UP.</a:t>
             </a:r>
             <a:endParaRPr sz="1600">
               <a:solidFill>
@@ -12447,7 +12447,7 @@
                 <a:ea typeface="Consolas"/>
                 <a:cs typeface="Consolas"/>
               </a:rPr>
-              <a:t>python monitor.py --reset --count 3 --interval 1
+              <a:t># Lanjutkan baseline lima check, tanpa reset.
 # Hentikan npm run dev Lab 08 (Ctrl+C).
 python monitor.py --count 2 --interval 1
 python report.py
@@ -12745,12 +12745,12 @@
                 <a:ea typeface="Aptos"/>
                 <a:cs typeface="Aptos"/>
               </a:rPr>
-              <a:t>Next.js memberi DOWN setelah gagal probe.
-Target lain tetap UP: isolasi dampak.
-2 kegagalan dari 5 → 60% jika total 5.
-Budget 99% untuk 5 cek = 0.05.
-Spent 2, sisa = -1.95 check.
-Nilai negatif = budget terlampaui.</a:t>
+              <a:t>Next terakhir DOWN, dua target tetap UP.
+Lima sehat + dua gagal: 5/7 = 71,43%.
+Budget 99% untuk 7 check = 0,07.
+Spent 2, sisa = -1,93 check.
+Tanpa reset, histori tetap dihitung.
+Sampel kelas belum menjadi SLO produksi.</a:t>
             </a:r>
             <a:endParaRPr sz="1600">
               <a:solidFill>
@@ -13092,7 +13092,7 @@
                 <a:ea typeface="Calibri"/>
                 <a:cs typeface="Calibri"/>
               </a:rPr>
-              <a:t>Simulasi insiden: Next.js dihentikan, API dan Gradio tetap hidup</a:t>
+              <a:t>Screenshot run sebelumnya memakai baseline 3 check, lalu 2 gagal. Modul terbaru memakai 5 check baseline.</a:t>
             </a:r>
             <a:endParaRPr sz="1200"/>
           </a:p>
@@ -14280,7 +14280,7 @@
                 <a:ea typeface="Calibri"/>
                 <a:cs typeface="Calibri"/>
               </a:rPr>
-              <a:t>Pemulihan simulasi insiden: Next.js UP, histori gagal tetap dihitung</a:t>
+              <a:t>Screenshot run sebelumnya: 3 sehat, 2 gagal, 1 pulih. Jumlah check modul terbaru berbeda.</a:t>
             </a:r>
             <a:endParaRPr sz="1200"/>
           </a:p>

</xml_diff>